<commit_message>
Replace presentations with corrected conflict-chain slide
</commit_message>
<xml_diff>
--- a/presentations/Adaptive-Budget-Allocation-for-Online-Advertising.pptx
+++ b/presentations/Adaptive-Budget-Allocation-for-Online-Advertising.pptx
@@ -2284,7 +2284,7 @@
           <a:p>
             <a:r>
               <a:rPr lang="en-US" dirty="0"/>
-              <a:t>Scenario 2 setup: four campaigns with values (0.95, 0.85, 0.78, 0.90), an 11-point bid grid on [0, 1] filtered by valuation (0 = opt out), conflicts 0–1–2–3 (adjacent campaigns cannot both bid). This gives 33 positive campaign/bid arms and 250 feasible super-actions; the maximum bid sum is 1.8. T = 3,000, B = 700, so rho = B/T ≈ 0.233. 20 paired trials. Competing thresholds: Beta marginals per campaign, (2,5), (2.8,3.8), (3.5,3), (2.3,4); with probability 0.3 all campaigns share one uniform quantile (cell 2), otherwise quantiles are independent. Cell 3 computes true arm means, cell 5 generates thresholds. Baseline: Combinatorial-UCB with semi-bandit feedback; cost lower bounds understate expenditure, so it spends too early (see the checkpoints on the next slide). Revision: KL win-probability bounds, empirical expected cost b·p̂ in the LP, and the cap rho_t = remaining budget / (T − t) with t counted from zero. The LP support is restricted to affordable super-actions (bid sum ≤ remaining budget); the null action is the fallback. The highlighted bids (C1 at 0.4, C3 at 0.3) are only an example of a feasible combination, not a recorded action. Sources: [R2] dynamic_budget_pacing.ipynb cells 2, 3, 5, 7, 10 and 12; [B2] baseline_combinatorial_ucb.ipynb cells 12 and 14.</a:t>
+              <a:t>Scenario 2 setup: four campaigns with values (0.95, 0.85, 0.78, 0.90), an 11-point bid grid on [0, 1] filtered by valuation (0 = opt out), conflicts 0–1–2–3 (adjacent campaigns cannot both bid). This gives 33 positive campaign/bid arms and 250 feasible super-actions; the maximum bid sum is 1.8. T = 3,000, B = 700, so rho = B/T ≈ 0.233. 20 paired trials. Competing thresholds: Beta marginals per campaign, (2,5), (2.8,3.8), (3.5,3), (2.3,4); with probability 0.3 all campaigns share one uniform quantile (cell 2), otherwise quantiles are independent. Cell 3 computes true arm means, cell 5 generates thresholds. Baseline: Combinatorial-UCB with semi-bandit feedback; cost lower bounds understate expenditure, so it spends too early (see the checkpoints on the next slide). Revision: KL win-probability bounds, empirical expected cost b·p̂ in the LP, and the cap rho_t = remaining budget / (T − t) with t counted from zero. The LP support is restricted to affordable super-actions (bid sum ≤ remaining budget); the null action is the fallback. The example round (C1 bids 0.4, C3 bids 0.3, so C2 and C4 cannot bid) only illustrates a feasible combination; it is not a recorded action. Sources: [R2] dynamic_budget_pacing.ipynb cells 2, 3, 5, 7, 10 and 12; [B2] baseline_combinatorial_ucb.ipynb cells 12 and 14.</a:t>
             </a:r>
             <a:endParaRPr lang="en-US" dirty="0"/>
           </a:p>
@@ -30359,7 +30359,7 @@
         <p:spPr>
           <a:xfrm>
             <a:off x="812800" y="1671241"/>
-            <a:ext cx="5232400" cy="1272431"/>
+            <a:ext cx="5232400" cy="772071"/>
           </a:xfrm>
           <a:prstGeom prst="rect">
             <a:avLst/>
@@ -30396,14 +30396,81 @@
       </p:sp>
       <p:sp>
         <p:nvSpPr>
-          <p:cNvPr id="5" name="Text 3"/>
-          <p:cNvSpPr/>
-          <p:nvPr/>
-        </p:nvSpPr>
-        <p:spPr>
-          <a:xfrm>
-            <a:off x="6299200" y="1671241"/>
-            <a:ext cx="5232400" cy="274290"/>
+          <p:cNvPr id="5" name="Shape 3"/>
+          <p:cNvSpPr/>
+          <p:nvPr/>
+        </p:nvSpPr>
+        <p:spPr>
+          <a:xfrm>
+            <a:off x="825500" y="2621111"/>
+            <a:ext cx="0" cy="530820"/>
+          </a:xfrm>
+          <a:prstGeom prst="line">
+            <a:avLst/>
+          </a:prstGeom>
+          <a:noFill/>
+          <a:ln w="25400">
+            <a:solidFill>
+              <a:srgbClr val="8D9AAE"/>
+            </a:solidFill>
+            <a:prstDash val="solid"/>
+          </a:ln>
+        </p:spPr>
+      </p:sp>
+      <p:sp>
+        <p:nvSpPr>
+          <p:cNvPr id="6" name="Text 4"/>
+          <p:cNvSpPr/>
+          <p:nvPr/>
+        </p:nvSpPr>
+        <p:spPr>
+          <a:xfrm>
+            <a:off x="990600" y="2621111"/>
+            <a:ext cx="5049266" cy="256530"/>
+          </a:xfrm>
+          <a:prstGeom prst="rect">
+            <a:avLst/>
+          </a:prstGeom>
+          <a:noFill/>
+          <a:ln/>
+        </p:spPr>
+        <p:txBody>
+          <a:bodyPr wrap="square" lIns="0" tIns="0" rIns="0" bIns="0" rtlCol="0" anchor="t">
+            <a:normAutofit/>
+          </a:bodyPr>
+          <a:lstStyle/>
+          <a:p>
+            <a:pPr algn="l" indent="0" marL="0">
+              <a:lnSpc>
+                <a:spcPts val="1820"/>
+              </a:lnSpc>
+              <a:buNone/>
+            </a:pPr>
+            <a:r>
+              <a:rPr lang="en-US" sz="1400" b="1" dirty="0">
+                <a:solidFill>
+                  <a:srgbClr val="5F6B7A"/>
+                </a:solidFill>
+                <a:latin typeface="IBM Plex Sans" pitchFamily="34" charset="0"/>
+                <a:ea typeface="IBM Plex Sans" pitchFamily="34" charset="-122"/>
+                <a:cs typeface="IBM Plex Sans" pitchFamily="34" charset="-120"/>
+              </a:rPr>
+              <a:t>Baseline</a:t>
+            </a:r>
+            <a:endParaRPr lang="en-US" sz="1400" dirty="0"/>
+          </a:p>
+        </p:txBody>
+      </p:sp>
+      <p:sp>
+        <p:nvSpPr>
+          <p:cNvPr id="7" name="Text 5"/>
+          <p:cNvSpPr/>
+          <p:nvPr/>
+        </p:nvSpPr>
+        <p:spPr>
+          <a:xfrm>
+            <a:off x="990600" y="2903041"/>
+            <a:ext cx="5049266" cy="274290"/>
           </a:xfrm>
           <a:prstGeom prst="rect">
             <a:avLst/>
@@ -30423,17 +30490,6 @@
               </a:lnSpc>
               <a:buNone/>
             </a:pPr>
-            <a:r>
-              <a:rPr lang="en-US" sz="1400" b="1" dirty="0">
-                <a:solidFill>
-                  <a:srgbClr val="46546A"/>
-                </a:solidFill>
-                <a:latin typeface="IBM Plex Sans" pitchFamily="34" charset="0"/>
-                <a:ea typeface="IBM Plex Sans" pitchFamily="34" charset="-122"/>
-                <a:cs typeface="IBM Plex Sans" pitchFamily="34" charset="-120"/>
-              </a:rPr>
-              <a:t>Baseline:</a:t>
-            </a:r>
             <a:r>
               <a:rPr lang="en-US" sz="1400" dirty="0">
                 <a:solidFill>
@@ -30443,7 +30499,7 @@
                 <a:ea typeface="IBM Plex Sans" pitchFamily="34" charset="-122"/>
                 <a:cs typeface="IBM Plex Sans" pitchFamily="34" charset="-120"/>
               </a:rPr>
-              <a:t> Combinatorial-UCB spends too early.</a:t>
+              <a:t>Combinatorial-UCB spends too early.</a:t>
             </a:r>
             <a:endParaRPr lang="en-US" sz="1400" dirty="0"/>
           </a:p>
@@ -30451,14 +30507,37 @@
       </p:sp>
       <p:sp>
         <p:nvSpPr>
-          <p:cNvPr id="6" name="Text 4"/>
-          <p:cNvSpPr/>
-          <p:nvPr/>
-        </p:nvSpPr>
-        <p:spPr>
-          <a:xfrm>
-            <a:off x="6299200" y="2021731"/>
-            <a:ext cx="5232400" cy="523180"/>
+          <p:cNvPr id="8" name="Shape 6"/>
+          <p:cNvSpPr/>
+          <p:nvPr/>
+        </p:nvSpPr>
+        <p:spPr>
+          <a:xfrm>
+            <a:off x="825500" y="3355132"/>
+            <a:ext cx="0" cy="1127671"/>
+          </a:xfrm>
+          <a:prstGeom prst="line">
+            <a:avLst/>
+          </a:prstGeom>
+          <a:noFill/>
+          <a:ln w="25400">
+            <a:solidFill>
+              <a:srgbClr val="B8492A"/>
+            </a:solidFill>
+            <a:prstDash val="solid"/>
+          </a:ln>
+        </p:spPr>
+      </p:sp>
+      <p:sp>
+        <p:nvSpPr>
+          <p:cNvPr id="9" name="Text 7"/>
+          <p:cNvSpPr/>
+          <p:nvPr/>
+        </p:nvSpPr>
+        <p:spPr>
+          <a:xfrm>
+            <a:off x="990600" y="3355132"/>
+            <a:ext cx="5049266" cy="256530"/>
           </a:xfrm>
           <a:prstGeom prst="rect">
             <a:avLst/>
@@ -30474,7 +30553,7 @@
           <a:p>
             <a:pPr algn="l" indent="0" marL="0">
               <a:lnSpc>
-                <a:spcPts val="1960"/>
+                <a:spcPts val="1820"/>
               </a:lnSpc>
               <a:buNone/>
             </a:pPr>
@@ -30487,8 +30566,41 @@
                 <a:ea typeface="IBM Plex Sans" pitchFamily="34" charset="-122"/>
                 <a:cs typeface="IBM Plex Sans" pitchFamily="34" charset="-120"/>
               </a:rPr>
-              <a:t>Revision:</a:t>
+              <a:t>Revision</a:t>
             </a:r>
+            <a:endParaRPr lang="en-US" sz="1400" dirty="0"/>
+          </a:p>
+        </p:txBody>
+      </p:sp>
+      <p:sp>
+        <p:nvSpPr>
+          <p:cNvPr id="10" name="Text 8"/>
+          <p:cNvSpPr/>
+          <p:nvPr/>
+        </p:nvSpPr>
+        <p:spPr>
+          <a:xfrm>
+            <a:off x="990600" y="3637062"/>
+            <a:ext cx="5049266" cy="523180"/>
+          </a:xfrm>
+          <a:prstGeom prst="rect">
+            <a:avLst/>
+          </a:prstGeom>
+          <a:noFill/>
+          <a:ln/>
+        </p:spPr>
+        <p:txBody>
+          <a:bodyPr wrap="square" lIns="0" tIns="0" rIns="0" bIns="0" rtlCol="0" anchor="t">
+            <a:normAutofit/>
+          </a:bodyPr>
+          <a:lstStyle/>
+          <a:p>
+            <a:pPr algn="l" indent="0" marL="0">
+              <a:lnSpc>
+                <a:spcPts val="1960"/>
+              </a:lnSpc>
+              <a:buNone/>
+            </a:pPr>
             <a:r>
               <a:rPr lang="en-US" sz="1400" dirty="0">
                 <a:solidFill>
@@ -30498,7 +30610,7 @@
                 <a:ea typeface="IBM Plex Sans" pitchFamily="34" charset="-122"/>
                 <a:cs typeface="IBM Plex Sans" pitchFamily="34" charset="-120"/>
               </a:rPr>
-              <a:t> keeps semi-bandit learning, with KL reward bounds, empirical expected costs and a remaining-budget cap.</a:t>
+              <a:t>Keeps semi-bandit learning, with KL reward bounds, empirical expected costs and a remaining-budget cap:</a:t>
             </a:r>
             <a:endParaRPr lang="en-US" sz="1400" dirty="0"/>
           </a:p>
@@ -30506,14 +30618,14 @@
       </p:sp>
       <p:sp>
         <p:nvSpPr>
-          <p:cNvPr id="7" name="Text 5"/>
-          <p:cNvSpPr/>
-          <p:nvPr/>
-        </p:nvSpPr>
-        <p:spPr>
-          <a:xfrm>
-            <a:off x="6299200" y="2621111"/>
-            <a:ext cx="5232400" cy="322560"/>
+          <p:cNvPr id="11" name="Text 9"/>
+          <p:cNvSpPr/>
+          <p:nvPr/>
+        </p:nvSpPr>
+        <p:spPr>
+          <a:xfrm>
+            <a:off x="990600" y="4185642"/>
+            <a:ext cx="5049266" cy="322560"/>
           </a:xfrm>
           <a:prstGeom prst="rect">
             <a:avLst/>
@@ -30550,14 +30662,14 @@
       </p:sp>
       <p:sp>
         <p:nvSpPr>
-          <p:cNvPr id="8" name="Text 6"/>
-          <p:cNvSpPr/>
-          <p:nvPr/>
-        </p:nvSpPr>
-        <p:spPr>
-          <a:xfrm>
-            <a:off x="812800" y="3172271"/>
-            <a:ext cx="10883392" cy="238720"/>
+          <p:cNvPr id="12" name="Text 10"/>
+          <p:cNvSpPr/>
+          <p:nvPr/>
+        </p:nvSpPr>
+        <p:spPr>
+          <a:xfrm>
+            <a:off x="812800" y="4686002"/>
+            <a:ext cx="5232400" cy="238720"/>
           </a:xfrm>
           <a:prstGeom prst="rect">
             <a:avLst/>
@@ -30572,824 +30684,6 @@
           <a:lstStyle/>
           <a:p>
             <a:pPr algn="l" indent="0" marL="0">
-              <a:lnSpc>
-                <a:spcPts val="1680"/>
-              </a:lnSpc>
-              <a:buNone/>
-            </a:pPr>
-            <a:r>
-              <a:rPr lang="en-US" sz="1200" spc="100" kern="0" dirty="0">
-                <a:solidFill>
-                  <a:srgbClr val="5F6B7A"/>
-                </a:solidFill>
-                <a:latin typeface="IBM Plex Mono" pitchFamily="49" charset="0"/>
-                <a:ea typeface="IBM Plex Mono" pitchFamily="49" charset="-122"/>
-                <a:cs typeface="IBM Plex Mono" pitchFamily="49" charset="-120"/>
-              </a:rPr>
-              <a:t>CONFLICT CHAIN · ADJACENT CAMPAIGNS CANNOT BID IN THE SAME ROUND</a:t>
-            </a:r>
-            <a:endParaRPr lang="en-US" sz="1200" dirty="0"/>
-          </a:p>
-        </p:txBody>
-      </p:sp>
-      <p:sp>
-        <p:nvSpPr>
-          <p:cNvPr id="9" name="Text 7"/>
-          <p:cNvSpPr/>
-          <p:nvPr/>
-        </p:nvSpPr>
-        <p:spPr>
-          <a:xfrm>
-            <a:off x="901700" y="3487192"/>
-            <a:ext cx="711200" cy="711200"/>
-          </a:xfrm>
-          <a:prstGeom prst="roundRect">
-            <a:avLst>
-              <a:gd name="adj" fmla="val 50000"/>
-            </a:avLst>
-          </a:prstGeom>
-          <a:solidFill>
-            <a:srgbClr val="14263D"/>
-          </a:solidFill>
-          <a:ln/>
-        </p:spPr>
-        <p:txBody>
-          <a:bodyPr wrap="square" lIns="0" tIns="0" rIns="0" bIns="0" rtlCol="0" anchor="ctr">
-            <a:normAutofit/>
-          </a:bodyPr>
-          <a:lstStyle/>
-          <a:p>
-            <a:pPr algn="ctr" indent="0" marL="0">
-              <a:lnSpc>
-                <a:spcPts val="1960"/>
-              </a:lnSpc>
-              <a:buNone/>
-            </a:pPr>
-            <a:r>
-              <a:rPr lang="en-US" sz="1400" b="1" dirty="0">
-                <a:solidFill>
-                  <a:srgbClr val="F2EFE8"/>
-                </a:solidFill>
-                <a:latin typeface="IBM Plex Sans" pitchFamily="34" charset="0"/>
-                <a:ea typeface="IBM Plex Sans" pitchFamily="34" charset="-122"/>
-                <a:cs typeface="IBM Plex Sans" pitchFamily="34" charset="-120"/>
-              </a:rPr>
-              <a:t>C1</a:t>
-            </a:r>
-            <a:endParaRPr lang="en-US" sz="1400" dirty="0"/>
-          </a:p>
-        </p:txBody>
-      </p:sp>
-      <p:sp>
-        <p:nvSpPr>
-          <p:cNvPr id="10" name="Shape 8"/>
-          <p:cNvSpPr/>
-          <p:nvPr/>
-        </p:nvSpPr>
-        <p:spPr>
-          <a:xfrm>
-            <a:off x="1803400" y="3830092"/>
-            <a:ext cx="2133600" cy="25400"/>
-          </a:xfrm>
-          <a:prstGeom prst="rect">
-            <a:avLst/>
-          </a:prstGeom>
-          <a:solidFill>
-            <a:srgbClr val="8D9AAE"/>
-          </a:solidFill>
-          <a:ln/>
-        </p:spPr>
-      </p:sp>
-      <p:sp>
-        <p:nvSpPr>
-          <p:cNvPr id="11" name="Text 9"/>
-          <p:cNvSpPr/>
-          <p:nvPr/>
-        </p:nvSpPr>
-        <p:spPr>
-          <a:xfrm>
-            <a:off x="4127500" y="3487192"/>
-            <a:ext cx="711200" cy="711200"/>
-          </a:xfrm>
-          <a:prstGeom prst="roundRect">
-            <a:avLst>
-              <a:gd name="adj" fmla="val 50000"/>
-            </a:avLst>
-          </a:prstGeom>
-          <a:solidFill>
-            <a:srgbClr val="14263D"/>
-          </a:solidFill>
-          <a:ln/>
-        </p:spPr>
-        <p:txBody>
-          <a:bodyPr wrap="square" lIns="0" tIns="0" rIns="0" bIns="0" rtlCol="0" anchor="ctr">
-            <a:normAutofit/>
-          </a:bodyPr>
-          <a:lstStyle/>
-          <a:p>
-            <a:pPr algn="ctr" indent="0" marL="0">
-              <a:lnSpc>
-                <a:spcPts val="1960"/>
-              </a:lnSpc>
-              <a:buNone/>
-            </a:pPr>
-            <a:r>
-              <a:rPr lang="en-US" sz="1400" b="1" dirty="0">
-                <a:solidFill>
-                  <a:srgbClr val="F2EFE8"/>
-                </a:solidFill>
-                <a:latin typeface="IBM Plex Sans" pitchFamily="34" charset="0"/>
-                <a:ea typeface="IBM Plex Sans" pitchFamily="34" charset="-122"/>
-                <a:cs typeface="IBM Plex Sans" pitchFamily="34" charset="-120"/>
-              </a:rPr>
-              <a:t>C2</a:t>
-            </a:r>
-            <a:endParaRPr lang="en-US" sz="1400" dirty="0"/>
-          </a:p>
-        </p:txBody>
-      </p:sp>
-      <p:sp>
-        <p:nvSpPr>
-          <p:cNvPr id="12" name="Shape 10"/>
-          <p:cNvSpPr/>
-          <p:nvPr/>
-        </p:nvSpPr>
-        <p:spPr>
-          <a:xfrm>
-            <a:off x="5029200" y="3830092"/>
-            <a:ext cx="2133600" cy="25400"/>
-          </a:xfrm>
-          <a:prstGeom prst="rect">
-            <a:avLst/>
-          </a:prstGeom>
-          <a:solidFill>
-            <a:srgbClr val="8D9AAE"/>
-          </a:solidFill>
-          <a:ln/>
-        </p:spPr>
-      </p:sp>
-      <p:sp>
-        <p:nvSpPr>
-          <p:cNvPr id="13" name="Text 11"/>
-          <p:cNvSpPr/>
-          <p:nvPr/>
-        </p:nvSpPr>
-        <p:spPr>
-          <a:xfrm>
-            <a:off x="7353300" y="3487192"/>
-            <a:ext cx="711200" cy="711200"/>
-          </a:xfrm>
-          <a:prstGeom prst="roundRect">
-            <a:avLst>
-              <a:gd name="adj" fmla="val 50000"/>
-            </a:avLst>
-          </a:prstGeom>
-          <a:solidFill>
-            <a:srgbClr val="14263D"/>
-          </a:solidFill>
-          <a:ln/>
-        </p:spPr>
-        <p:txBody>
-          <a:bodyPr wrap="square" lIns="0" tIns="0" rIns="0" bIns="0" rtlCol="0" anchor="ctr">
-            <a:normAutofit/>
-          </a:bodyPr>
-          <a:lstStyle/>
-          <a:p>
-            <a:pPr algn="ctr" indent="0" marL="0">
-              <a:lnSpc>
-                <a:spcPts val="1960"/>
-              </a:lnSpc>
-              <a:buNone/>
-            </a:pPr>
-            <a:r>
-              <a:rPr lang="en-US" sz="1400" b="1" dirty="0">
-                <a:solidFill>
-                  <a:srgbClr val="F2EFE8"/>
-                </a:solidFill>
-                <a:latin typeface="IBM Plex Sans" pitchFamily="34" charset="0"/>
-                <a:ea typeface="IBM Plex Sans" pitchFamily="34" charset="-122"/>
-                <a:cs typeface="IBM Plex Sans" pitchFamily="34" charset="-120"/>
-              </a:rPr>
-              <a:t>C3</a:t>
-            </a:r>
-            <a:endParaRPr lang="en-US" sz="1400" dirty="0"/>
-          </a:p>
-        </p:txBody>
-      </p:sp>
-      <p:sp>
-        <p:nvSpPr>
-          <p:cNvPr id="14" name="Shape 12"/>
-          <p:cNvSpPr/>
-          <p:nvPr/>
-        </p:nvSpPr>
-        <p:spPr>
-          <a:xfrm>
-            <a:off x="8255000" y="3830092"/>
-            <a:ext cx="2133600" cy="25400"/>
-          </a:xfrm>
-          <a:prstGeom prst="rect">
-            <a:avLst/>
-          </a:prstGeom>
-          <a:solidFill>
-            <a:srgbClr val="8D9AAE"/>
-          </a:solidFill>
-          <a:ln/>
-        </p:spPr>
-      </p:sp>
-      <p:sp>
-        <p:nvSpPr>
-          <p:cNvPr id="15" name="Text 13"/>
-          <p:cNvSpPr/>
-          <p:nvPr/>
-        </p:nvSpPr>
-        <p:spPr>
-          <a:xfrm>
-            <a:off x="10579100" y="3487192"/>
-            <a:ext cx="711200" cy="711200"/>
-          </a:xfrm>
-          <a:prstGeom prst="roundRect">
-            <a:avLst>
-              <a:gd name="adj" fmla="val 50000"/>
-            </a:avLst>
-          </a:prstGeom>
-          <a:solidFill>
-            <a:srgbClr val="14263D"/>
-          </a:solidFill>
-          <a:ln/>
-        </p:spPr>
-        <p:txBody>
-          <a:bodyPr wrap="square" lIns="0" tIns="0" rIns="0" bIns="0" rtlCol="0" anchor="ctr">
-            <a:normAutofit/>
-          </a:bodyPr>
-          <a:lstStyle/>
-          <a:p>
-            <a:pPr algn="ctr" indent="0" marL="0">
-              <a:lnSpc>
-                <a:spcPts val="1960"/>
-              </a:lnSpc>
-              <a:buNone/>
-            </a:pPr>
-            <a:r>
-              <a:rPr lang="en-US" sz="1400" b="1" dirty="0">
-                <a:solidFill>
-                  <a:srgbClr val="F2EFE8"/>
-                </a:solidFill>
-                <a:latin typeface="IBM Plex Sans" pitchFamily="34" charset="0"/>
-                <a:ea typeface="IBM Plex Sans" pitchFamily="34" charset="-122"/>
-                <a:cs typeface="IBM Plex Sans" pitchFamily="34" charset="-120"/>
-              </a:rPr>
-              <a:t>C4</a:t>
-            </a:r>
-            <a:endParaRPr lang="en-US" sz="1400" dirty="0"/>
-          </a:p>
-        </p:txBody>
-      </p:sp>
-      <p:sp>
-        <p:nvSpPr>
-          <p:cNvPr id="16" name="Text 14"/>
-          <p:cNvSpPr/>
-          <p:nvPr/>
-        </p:nvSpPr>
-        <p:spPr>
-          <a:xfrm>
-            <a:off x="787400" y="4338092"/>
-            <a:ext cx="939800" cy="238720"/>
-          </a:xfrm>
-          <a:prstGeom prst="rect">
-            <a:avLst/>
-          </a:prstGeom>
-          <a:noFill/>
-          <a:ln/>
-        </p:spPr>
-        <p:txBody>
-          <a:bodyPr wrap="square" lIns="0" tIns="0" rIns="0" bIns="0" rtlCol="0" anchor="t">
-            <a:normAutofit/>
-          </a:bodyPr>
-          <a:lstStyle/>
-          <a:p>
-            <a:pPr algn="ctr" indent="0" marL="0">
-              <a:lnSpc>
-                <a:spcPts val="1680"/>
-              </a:lnSpc>
-              <a:buNone/>
-            </a:pPr>
-            <a:r>
-              <a:rPr lang="en-US" sz="1200" dirty="0">
-                <a:solidFill>
-                  <a:srgbClr val="46546A"/>
-                </a:solidFill>
-                <a:latin typeface="IBM Plex Sans" pitchFamily="34" charset="0"/>
-                <a:ea typeface="IBM Plex Sans" pitchFamily="34" charset="-122"/>
-                <a:cs typeface="IBM Plex Sans" pitchFamily="34" charset="-120"/>
-              </a:rPr>
-              <a:t>v = 0.95</a:t>
-            </a:r>
-            <a:endParaRPr lang="en-US" sz="1200" dirty="0"/>
-          </a:p>
-        </p:txBody>
-      </p:sp>
-      <p:sp>
-        <p:nvSpPr>
-          <p:cNvPr id="17" name="Text 15"/>
-          <p:cNvSpPr/>
-          <p:nvPr/>
-        </p:nvSpPr>
-        <p:spPr>
-          <a:xfrm>
-            <a:off x="1771396" y="4338092"/>
-            <a:ext cx="2197608" cy="238720"/>
-          </a:xfrm>
-          <a:prstGeom prst="rect">
-            <a:avLst/>
-          </a:prstGeom>
-          <a:noFill/>
-          <a:ln/>
-        </p:spPr>
-        <p:txBody>
-          <a:bodyPr wrap="square" lIns="0" tIns="0" rIns="0" bIns="0" rtlCol="0" anchor="t">
-            <a:normAutofit/>
-          </a:bodyPr>
-          <a:lstStyle/>
-          <a:p>
-            <a:pPr algn="ctr" indent="0" marL="0">
-              <a:lnSpc>
-                <a:spcPts val="1680"/>
-              </a:lnSpc>
-              <a:buNone/>
-            </a:pPr>
-            <a:r>
-              <a:rPr lang="en-US" sz="1200" dirty="0">
-                <a:solidFill>
-                  <a:srgbClr val="46546A"/>
-                </a:solidFill>
-                <a:latin typeface="IBM Plex Sans" pitchFamily="34" charset="0"/>
-                <a:ea typeface="IBM Plex Sans" pitchFamily="34" charset="-122"/>
-                <a:cs typeface="IBM Plex Sans" pitchFamily="34" charset="-120"/>
-              </a:rPr>
-              <a:t>v = 0.85</a:t>
-            </a:r>
-            <a:endParaRPr lang="en-US" sz="1200" dirty="0"/>
-          </a:p>
-        </p:txBody>
-      </p:sp>
-      <p:sp>
-        <p:nvSpPr>
-          <p:cNvPr id="18" name="Text 16"/>
-          <p:cNvSpPr/>
-          <p:nvPr/>
-        </p:nvSpPr>
-        <p:spPr>
-          <a:xfrm>
-            <a:off x="4013200" y="4338092"/>
-            <a:ext cx="939800" cy="238720"/>
-          </a:xfrm>
-          <a:prstGeom prst="rect">
-            <a:avLst/>
-          </a:prstGeom>
-          <a:noFill/>
-          <a:ln/>
-        </p:spPr>
-        <p:txBody>
-          <a:bodyPr wrap="square" lIns="0" tIns="0" rIns="0" bIns="0" rtlCol="0" anchor="t">
-            <a:normAutofit/>
-          </a:bodyPr>
-          <a:lstStyle/>
-          <a:p>
-            <a:pPr algn="ctr" indent="0" marL="0">
-              <a:lnSpc>
-                <a:spcPts val="1680"/>
-              </a:lnSpc>
-              <a:buNone/>
-            </a:pPr>
-            <a:r>
-              <a:rPr lang="en-US" sz="1200" dirty="0">
-                <a:solidFill>
-                  <a:srgbClr val="46546A"/>
-                </a:solidFill>
-                <a:latin typeface="IBM Plex Sans" pitchFamily="34" charset="0"/>
-                <a:ea typeface="IBM Plex Sans" pitchFamily="34" charset="-122"/>
-                <a:cs typeface="IBM Plex Sans" pitchFamily="34" charset="-120"/>
-              </a:rPr>
-              <a:t>v = 0.78</a:t>
-            </a:r>
-            <a:endParaRPr lang="en-US" sz="1200" dirty="0"/>
-          </a:p>
-        </p:txBody>
-      </p:sp>
-      <p:sp>
-        <p:nvSpPr>
-          <p:cNvPr id="19" name="Text 17"/>
-          <p:cNvSpPr/>
-          <p:nvPr/>
-        </p:nvSpPr>
-        <p:spPr>
-          <a:xfrm>
-            <a:off x="4997196" y="4338092"/>
-            <a:ext cx="2197608" cy="238720"/>
-          </a:xfrm>
-          <a:prstGeom prst="rect">
-            <a:avLst/>
-          </a:prstGeom>
-          <a:noFill/>
-          <a:ln/>
-        </p:spPr>
-        <p:txBody>
-          <a:bodyPr wrap="square" lIns="0" tIns="0" rIns="0" bIns="0" rtlCol="0" anchor="t">
-            <a:normAutofit/>
-          </a:bodyPr>
-          <a:lstStyle/>
-          <a:p>
-            <a:pPr algn="ctr" indent="0" marL="0">
-              <a:lnSpc>
-                <a:spcPts val="1680"/>
-              </a:lnSpc>
-              <a:buNone/>
-            </a:pPr>
-            <a:r>
-              <a:rPr lang="en-US" sz="1200" dirty="0">
-                <a:solidFill>
-                  <a:srgbClr val="46546A"/>
-                </a:solidFill>
-                <a:latin typeface="IBM Plex Sans" pitchFamily="34" charset="0"/>
-                <a:ea typeface="IBM Plex Sans" pitchFamily="34" charset="-122"/>
-                <a:cs typeface="IBM Plex Sans" pitchFamily="34" charset="-120"/>
-              </a:rPr>
-              <a:t>v = 0.90</a:t>
-            </a:r>
-            <a:endParaRPr lang="en-US" sz="1200" dirty="0"/>
-          </a:p>
-        </p:txBody>
-      </p:sp>
-      <p:sp>
-        <p:nvSpPr>
-          <p:cNvPr id="20" name="Text 18"/>
-          <p:cNvSpPr/>
-          <p:nvPr/>
-        </p:nvSpPr>
-        <p:spPr>
-          <a:xfrm>
-            <a:off x="7264400" y="4299992"/>
-            <a:ext cx="889000" cy="289520"/>
-          </a:xfrm>
-          <a:custGeom>
-            <a:avLst/>
-            <a:gdLst/>
-            <a:ahLst/>
-            <a:cxnLst/>
-            <a:rect l="l" t="t" r="r" b="b"/>
-            <a:pathLst>
-              <a:path w="889000" h="289520">
-                <a:moveTo>
-                  <a:pt x="144760" y="0"/>
-                </a:moveTo>
-                <a:lnTo>
-                  <a:pt x="744240" y="0"/>
-                </a:lnTo>
-                <a:arcTo hR="144760" wR="144760" stAng="16200000" swAng="5400000"/>
-                <a:lnTo>
-                  <a:pt x="889000" y="144760"/>
-                </a:lnTo>
-                <a:arcTo hR="144760" wR="144760" stAng="0" swAng="5400000"/>
-                <a:lnTo>
-                  <a:pt x="144760" y="289520"/>
-                </a:lnTo>
-                <a:arcTo hR="144760" wR="144760" stAng="5400000" swAng="5400000"/>
-                <a:lnTo>
-                  <a:pt x="0" y="144760"/>
-                </a:lnTo>
-                <a:arcTo hR="144760" wR="144760" stAng="10800000" swAng="5400000"/>
-                <a:close/>
-              </a:path>
-            </a:pathLst>
-          </a:custGeom>
-          <a:solidFill>
-            <a:srgbClr val="B8492A"/>
-          </a:solidFill>
-          <a:ln/>
-        </p:spPr>
-        <p:txBody>
-          <a:bodyPr wrap="square" lIns="25400" tIns="38100" rIns="25400" bIns="12700" rtlCol="0" anchor="t">
-            <a:normAutofit/>
-          </a:bodyPr>
-          <a:lstStyle/>
-          <a:p>
-            <a:pPr algn="ctr" indent="0" marL="0">
-              <a:lnSpc>
-                <a:spcPts val="1680"/>
-              </a:lnSpc>
-              <a:buNone/>
-            </a:pPr>
-            <a:r>
-              <a:rPr lang="en-US" sz="1200" b="1" dirty="0">
-                <a:solidFill>
-                  <a:srgbClr val="FCFBF8"/>
-                </a:solidFill>
-                <a:latin typeface="IBM Plex Sans" pitchFamily="34" charset="0"/>
-                <a:ea typeface="IBM Plex Sans" pitchFamily="34" charset="-122"/>
-                <a:cs typeface="IBM Plex Sans" pitchFamily="34" charset="-120"/>
-              </a:rPr>
-              <a:t>bid 0.4</a:t>
-            </a:r>
-            <a:endParaRPr lang="en-US" sz="1200" dirty="0"/>
-          </a:p>
-        </p:txBody>
-      </p:sp>
-      <p:sp>
-        <p:nvSpPr>
-          <p:cNvPr id="21" name="Text 19"/>
-          <p:cNvSpPr/>
-          <p:nvPr/>
-        </p:nvSpPr>
-        <p:spPr>
-          <a:xfrm>
-            <a:off x="8261350" y="4306342"/>
-            <a:ext cx="2120900" cy="276820"/>
-          </a:xfrm>
-          <a:custGeom>
-            <a:avLst/>
-            <a:gdLst/>
-            <a:ahLst/>
-            <a:cxnLst/>
-            <a:rect l="l" t="t" r="r" b="b"/>
-            <a:pathLst>
-              <a:path w="2120900" h="276820">
-                <a:moveTo>
-                  <a:pt x="138410" y="0"/>
-                </a:moveTo>
-                <a:lnTo>
-                  <a:pt x="1982490" y="0"/>
-                </a:lnTo>
-                <a:arcTo hR="138410" wR="138410" stAng="16200000" swAng="5400000"/>
-                <a:lnTo>
-                  <a:pt x="2120900" y="138410"/>
-                </a:lnTo>
-                <a:arcTo hR="138410" wR="138410" stAng="0" swAng="5400000"/>
-                <a:lnTo>
-                  <a:pt x="138410" y="276820"/>
-                </a:lnTo>
-                <a:arcTo hR="138410" wR="138410" stAng="5400000" swAng="5400000"/>
-                <a:lnTo>
-                  <a:pt x="0" y="138410"/>
-                </a:lnTo>
-                <a:arcTo hR="138410" wR="138410" stAng="10800000" swAng="5400000"/>
-                <a:close/>
-              </a:path>
-            </a:pathLst>
-          </a:custGeom>
-          <a:noFill/>
-          <a:ln w="12700">
-            <a:solidFill>
-              <a:srgbClr val="A9B4C2"/>
-            </a:solidFill>
-            <a:prstDash val="solid"/>
-          </a:ln>
-        </p:spPr>
-        <p:txBody>
-          <a:bodyPr wrap="square" lIns="27051" tIns="31750" rIns="27051" bIns="6350" rtlCol="0" anchor="t">
-            <a:normAutofit/>
-          </a:bodyPr>
-          <a:lstStyle/>
-          <a:p>
-            <a:pPr algn="ctr" indent="0" marL="0">
-              <a:lnSpc>
-                <a:spcPts val="1680"/>
-              </a:lnSpc>
-              <a:buNone/>
-            </a:pPr>
-            <a:r>
-              <a:rPr lang="en-US" sz="1200" dirty="0">
-                <a:solidFill>
-                  <a:srgbClr val="5F6B7A"/>
-                </a:solidFill>
-                <a:latin typeface="IBM Plex Sans" pitchFamily="34" charset="0"/>
-                <a:ea typeface="IBM Plex Sans" pitchFamily="34" charset="-122"/>
-                <a:cs typeface="IBM Plex Sans" pitchFamily="34" charset="-120"/>
-              </a:rPr>
-              <a:t>no bid</a:t>
-            </a:r>
-            <a:endParaRPr lang="en-US" sz="1200" dirty="0"/>
-          </a:p>
-        </p:txBody>
-      </p:sp>
-      <p:sp>
-        <p:nvSpPr>
-          <p:cNvPr id="22" name="Text 20"/>
-          <p:cNvSpPr/>
-          <p:nvPr/>
-        </p:nvSpPr>
-        <p:spPr>
-          <a:xfrm>
-            <a:off x="10490200" y="4299992"/>
-            <a:ext cx="889000" cy="289520"/>
-          </a:xfrm>
-          <a:custGeom>
-            <a:avLst/>
-            <a:gdLst/>
-            <a:ahLst/>
-            <a:cxnLst/>
-            <a:rect l="l" t="t" r="r" b="b"/>
-            <a:pathLst>
-              <a:path w="889000" h="289520">
-                <a:moveTo>
-                  <a:pt x="144760" y="0"/>
-                </a:moveTo>
-                <a:lnTo>
-                  <a:pt x="744240" y="0"/>
-                </a:lnTo>
-                <a:arcTo hR="144760" wR="144760" stAng="16200000" swAng="5400000"/>
-                <a:lnTo>
-                  <a:pt x="889000" y="144760"/>
-                </a:lnTo>
-                <a:arcTo hR="144760" wR="144760" stAng="0" swAng="5400000"/>
-                <a:lnTo>
-                  <a:pt x="144760" y="289520"/>
-                </a:lnTo>
-                <a:arcTo hR="144760" wR="144760" stAng="5400000" swAng="5400000"/>
-                <a:lnTo>
-                  <a:pt x="0" y="144760"/>
-                </a:lnTo>
-                <a:arcTo hR="144760" wR="144760" stAng="10800000" swAng="5400000"/>
-                <a:close/>
-              </a:path>
-            </a:pathLst>
-          </a:custGeom>
-          <a:solidFill>
-            <a:srgbClr val="B8492A"/>
-          </a:solidFill>
-          <a:ln/>
-        </p:spPr>
-        <p:txBody>
-          <a:bodyPr wrap="square" lIns="25400" tIns="38100" rIns="25400" bIns="12700" rtlCol="0" anchor="t">
-            <a:normAutofit/>
-          </a:bodyPr>
-          <a:lstStyle/>
-          <a:p>
-            <a:pPr algn="ctr" indent="0" marL="0">
-              <a:lnSpc>
-                <a:spcPts val="1680"/>
-              </a:lnSpc>
-              <a:buNone/>
-            </a:pPr>
-            <a:r>
-              <a:rPr lang="en-US" sz="1200" b="1" dirty="0">
-                <a:solidFill>
-                  <a:srgbClr val="FCFBF8"/>
-                </a:solidFill>
-                <a:latin typeface="IBM Plex Sans" pitchFamily="34" charset="0"/>
-                <a:ea typeface="IBM Plex Sans" pitchFamily="34" charset="-122"/>
-                <a:cs typeface="IBM Plex Sans" pitchFamily="34" charset="-120"/>
-              </a:rPr>
-              <a:t>bid 0.3</a:t>
-            </a:r>
-            <a:endParaRPr lang="en-US" sz="1200" dirty="0"/>
-          </a:p>
-        </p:txBody>
-      </p:sp>
-      <p:sp>
-        <p:nvSpPr>
-          <p:cNvPr id="23" name="Text 21"/>
-          <p:cNvSpPr/>
-          <p:nvPr/>
-        </p:nvSpPr>
-        <p:spPr>
-          <a:xfrm>
-            <a:off x="819150" y="4697462"/>
-            <a:ext cx="876300" cy="276820"/>
-          </a:xfrm>
-          <a:custGeom>
-            <a:avLst/>
-            <a:gdLst/>
-            <a:ahLst/>
-            <a:cxnLst/>
-            <a:rect l="l" t="t" r="r" b="b"/>
-            <a:pathLst>
-              <a:path w="876300" h="276820">
-                <a:moveTo>
-                  <a:pt x="138410" y="0"/>
-                </a:moveTo>
-                <a:lnTo>
-                  <a:pt x="737890" y="0"/>
-                </a:lnTo>
-                <a:arcTo hR="138410" wR="138410" stAng="16200000" swAng="5400000"/>
-                <a:lnTo>
-                  <a:pt x="876300" y="138410"/>
-                </a:lnTo>
-                <a:arcTo hR="138410" wR="138410" stAng="0" swAng="5400000"/>
-                <a:lnTo>
-                  <a:pt x="138410" y="276820"/>
-                </a:lnTo>
-                <a:arcTo hR="138410" wR="138410" stAng="5400000" swAng="5400000"/>
-                <a:lnTo>
-                  <a:pt x="0" y="138410"/>
-                </a:lnTo>
-                <a:arcTo hR="138410" wR="138410" stAng="10800000" swAng="5400000"/>
-                <a:close/>
-              </a:path>
-            </a:pathLst>
-          </a:custGeom>
-          <a:noFill/>
-          <a:ln w="12700">
-            <a:solidFill>
-              <a:srgbClr val="A9B4C2"/>
-            </a:solidFill>
-            <a:prstDash val="solid"/>
-          </a:ln>
-        </p:spPr>
-        <p:txBody>
-          <a:bodyPr wrap="square" lIns="31750" tIns="31750" rIns="31750" bIns="6350" rtlCol="0" anchor="t">
-            <a:normAutofit/>
-          </a:bodyPr>
-          <a:lstStyle/>
-          <a:p>
-            <a:pPr algn="ctr" indent="0" marL="0">
-              <a:lnSpc>
-                <a:spcPts val="1680"/>
-              </a:lnSpc>
-              <a:buNone/>
-            </a:pPr>
-            <a:r>
-              <a:rPr lang="en-US" sz="1200" dirty="0">
-                <a:solidFill>
-                  <a:srgbClr val="5F6B7A"/>
-                </a:solidFill>
-                <a:latin typeface="IBM Plex Sans" pitchFamily="34" charset="0"/>
-                <a:ea typeface="IBM Plex Sans" pitchFamily="34" charset="-122"/>
-                <a:cs typeface="IBM Plex Sans" pitchFamily="34" charset="-120"/>
-              </a:rPr>
-              <a:t>no bid</a:t>
-            </a:r>
-            <a:endParaRPr lang="en-US" sz="1200" dirty="0"/>
-          </a:p>
-        </p:txBody>
-      </p:sp>
-      <p:sp>
-        <p:nvSpPr>
-          <p:cNvPr id="24" name="Text 22"/>
-          <p:cNvSpPr/>
-          <p:nvPr/>
-        </p:nvSpPr>
-        <p:spPr>
-          <a:xfrm>
-            <a:off x="812800" y="5082232"/>
-            <a:ext cx="4481691" cy="238720"/>
-          </a:xfrm>
-          <a:prstGeom prst="rect">
-            <a:avLst/>
-          </a:prstGeom>
-          <a:noFill/>
-          <a:ln/>
-        </p:spPr>
-        <p:txBody>
-          <a:bodyPr wrap="square" lIns="0" tIns="0" rIns="0" bIns="0" rtlCol="0" anchor="t">
-            <a:normAutofit/>
-          </a:bodyPr>
-          <a:lstStyle/>
-          <a:p>
-            <a:pPr algn="l" indent="0" marL="0">
-              <a:lnSpc>
-                <a:spcPts val="1680"/>
-              </a:lnSpc>
-              <a:buNone/>
-            </a:pPr>
-            <a:r>
-              <a:rPr lang="en-US" sz="1200" dirty="0">
-                <a:solidFill>
-                  <a:srgbClr val="5F6B7A"/>
-                </a:solidFill>
-                <a:latin typeface="IBM Plex Sans" pitchFamily="34" charset="0"/>
-                <a:ea typeface="IBM Plex Sans" pitchFamily="34" charset="-122"/>
-                <a:cs typeface="IBM Plex Sans" pitchFamily="34" charset="-120"/>
-              </a:rPr>
-              <a:t>Illustrative feasible combination, not a recorded action</a:t>
-            </a:r>
-            <a:endParaRPr lang="en-US" sz="1200" dirty="0"/>
-          </a:p>
-        </p:txBody>
-      </p:sp>
-      <p:sp>
-        <p:nvSpPr>
-          <p:cNvPr id="25" name="Text 23"/>
-          <p:cNvSpPr/>
-          <p:nvPr/>
-        </p:nvSpPr>
-        <p:spPr>
-          <a:xfrm>
-            <a:off x="6656645" y="5082232"/>
-            <a:ext cx="4722555" cy="238720"/>
-          </a:xfrm>
-          <a:prstGeom prst="rect">
-            <a:avLst/>
-          </a:prstGeom>
-          <a:noFill/>
-          <a:ln/>
-        </p:spPr>
-        <p:txBody>
-          <a:bodyPr wrap="square" lIns="0" tIns="0" rIns="0" bIns="0" rtlCol="0" anchor="t">
-            <a:normAutofit/>
-          </a:bodyPr>
-          <a:lstStyle/>
-          <a:p>
-            <a:pPr algn="r" indent="0" marL="0">
               <a:lnSpc>
                 <a:spcPts val="1680"/>
               </a:lnSpc>
@@ -31412,7 +30706,852 @@
       </p:sp>
       <p:sp>
         <p:nvSpPr>
-          <p:cNvPr id="26" name="Text 24"/>
+          <p:cNvPr id="13" name="Shape 11"/>
+          <p:cNvSpPr/>
+          <p:nvPr/>
+        </p:nvSpPr>
+        <p:spPr>
+          <a:xfrm>
+            <a:off x="6302375" y="1674416"/>
+            <a:ext cx="5073650" cy="3897511"/>
+          </a:xfrm>
+          <a:prstGeom prst="roundRect">
+            <a:avLst>
+              <a:gd name="adj" fmla="val 1874"/>
+            </a:avLst>
+          </a:prstGeom>
+          <a:solidFill>
+            <a:srgbClr val="FCFBF8"/>
+          </a:solidFill>
+          <a:ln w="6350">
+            <a:solidFill>
+              <a:srgbClr val="DCD8CF"/>
+            </a:solidFill>
+            <a:prstDash val="solid"/>
+          </a:ln>
+        </p:spPr>
+      </p:sp>
+      <p:sp>
+        <p:nvSpPr>
+          <p:cNvPr id="14" name="Text 12"/>
+          <p:cNvSpPr/>
+          <p:nvPr/>
+        </p:nvSpPr>
+        <p:spPr>
+          <a:xfrm>
+            <a:off x="6508750" y="1855391"/>
+            <a:ext cx="4800727" cy="238720"/>
+          </a:xfrm>
+          <a:prstGeom prst="rect">
+            <a:avLst/>
+          </a:prstGeom>
+          <a:noFill/>
+          <a:ln/>
+        </p:spPr>
+        <p:txBody>
+          <a:bodyPr wrap="square" lIns="0" tIns="0" rIns="0" bIns="0" rtlCol="0" anchor="t">
+            <a:normAutofit/>
+          </a:bodyPr>
+          <a:lstStyle/>
+          <a:p>
+            <a:pPr algn="l" indent="0" marL="0">
+              <a:lnSpc>
+                <a:spcPts val="1680"/>
+              </a:lnSpc>
+              <a:buNone/>
+            </a:pPr>
+            <a:r>
+              <a:rPr lang="en-US" sz="1200" spc="100" kern="0" dirty="0">
+                <a:solidFill>
+                  <a:srgbClr val="5F6B7A"/>
+                </a:solidFill>
+                <a:latin typeface="IBM Plex Mono" pitchFamily="49" charset="0"/>
+                <a:ea typeface="IBM Plex Mono" pitchFamily="49" charset="-122"/>
+                <a:cs typeface="IBM Plex Mono" pitchFamily="49" charset="-120"/>
+              </a:rPr>
+              <a:t>CONFLICT CHAIN · EXAMPLE ROUND</a:t>
+            </a:r>
+            <a:endParaRPr lang="en-US" sz="1200" dirty="0"/>
+          </a:p>
+        </p:txBody>
+      </p:sp>
+      <p:sp>
+        <p:nvSpPr>
+          <p:cNvPr id="15" name="Text 13"/>
+          <p:cNvSpPr/>
+          <p:nvPr/>
+        </p:nvSpPr>
+        <p:spPr>
+          <a:xfrm>
+            <a:off x="6508750" y="2144911"/>
+            <a:ext cx="457200" cy="457200"/>
+          </a:xfrm>
+          <a:prstGeom prst="roundRect">
+            <a:avLst>
+              <a:gd name="adj" fmla="val 50000"/>
+            </a:avLst>
+          </a:prstGeom>
+          <a:solidFill>
+            <a:srgbClr val="14263D"/>
+          </a:solidFill>
+          <a:ln/>
+        </p:spPr>
+        <p:txBody>
+          <a:bodyPr wrap="square" lIns="0" tIns="0" rIns="0" bIns="0" rtlCol="0" anchor="ctr">
+            <a:normAutofit/>
+          </a:bodyPr>
+          <a:lstStyle/>
+          <a:p>
+            <a:pPr algn="ctr" indent="0" marL="0">
+              <a:lnSpc>
+                <a:spcPts val="1680"/>
+              </a:lnSpc>
+              <a:buNone/>
+            </a:pPr>
+            <a:r>
+              <a:rPr lang="en-US" sz="1200" b="1" dirty="0">
+                <a:solidFill>
+                  <a:srgbClr val="F2EFE8"/>
+                </a:solidFill>
+                <a:latin typeface="IBM Plex Sans" pitchFamily="34" charset="0"/>
+                <a:ea typeface="IBM Plex Sans" pitchFamily="34" charset="-122"/>
+                <a:cs typeface="IBM Plex Sans" pitchFamily="34" charset="-120"/>
+              </a:rPr>
+              <a:t>C1</a:t>
+            </a:r>
+            <a:endParaRPr lang="en-US" sz="1200" dirty="0"/>
+          </a:p>
+        </p:txBody>
+      </p:sp>
+      <p:sp>
+        <p:nvSpPr>
+          <p:cNvPr id="16" name="Text 14"/>
+          <p:cNvSpPr/>
+          <p:nvPr/>
+        </p:nvSpPr>
+        <p:spPr>
+          <a:xfrm>
+            <a:off x="7118350" y="2266851"/>
+            <a:ext cx="1066800" cy="238720"/>
+          </a:xfrm>
+          <a:prstGeom prst="rect">
+            <a:avLst/>
+          </a:prstGeom>
+          <a:noFill/>
+          <a:ln/>
+        </p:spPr>
+        <p:txBody>
+          <a:bodyPr wrap="square" lIns="0" tIns="0" rIns="0" bIns="0" rtlCol="0" anchor="t">
+            <a:normAutofit/>
+          </a:bodyPr>
+          <a:lstStyle/>
+          <a:p>
+            <a:pPr algn="l" indent="0" marL="0">
+              <a:lnSpc>
+                <a:spcPts val="1680"/>
+              </a:lnSpc>
+              <a:buNone/>
+            </a:pPr>
+            <a:r>
+              <a:rPr lang="en-US" sz="1200" dirty="0">
+                <a:solidFill>
+                  <a:srgbClr val="46546A"/>
+                </a:solidFill>
+                <a:latin typeface="IBM Plex Sans" pitchFamily="34" charset="0"/>
+                <a:ea typeface="IBM Plex Sans" pitchFamily="34" charset="-122"/>
+                <a:cs typeface="IBM Plex Sans" pitchFamily="34" charset="-120"/>
+              </a:rPr>
+              <a:t>value 0.95</a:t>
+            </a:r>
+            <a:endParaRPr lang="en-US" sz="1200" dirty="0"/>
+          </a:p>
+        </p:txBody>
+      </p:sp>
+      <p:sp>
+        <p:nvSpPr>
+          <p:cNvPr id="17" name="Text 15"/>
+          <p:cNvSpPr/>
+          <p:nvPr/>
+        </p:nvSpPr>
+        <p:spPr>
+          <a:xfrm>
+            <a:off x="8286750" y="2241451"/>
+            <a:ext cx="768499" cy="264120"/>
+          </a:xfrm>
+          <a:custGeom>
+            <a:avLst/>
+            <a:gdLst/>
+            <a:ahLst/>
+            <a:cxnLst/>
+            <a:rect l="l" t="t" r="r" b="b"/>
+            <a:pathLst>
+              <a:path w="768499" h="264120">
+                <a:moveTo>
+                  <a:pt x="132060" y="0"/>
+                </a:moveTo>
+                <a:lnTo>
+                  <a:pt x="636439" y="0"/>
+                </a:lnTo>
+                <a:arcTo hR="132060" wR="132060" stAng="16200000" swAng="5400000"/>
+                <a:lnTo>
+                  <a:pt x="768499" y="132060"/>
+                </a:lnTo>
+                <a:arcTo hR="132060" wR="132060" stAng="0" swAng="5400000"/>
+                <a:lnTo>
+                  <a:pt x="132060" y="264120"/>
+                </a:lnTo>
+                <a:arcTo hR="132060" wR="132060" stAng="5400000" swAng="5400000"/>
+                <a:lnTo>
+                  <a:pt x="0" y="132060"/>
+                </a:lnTo>
+                <a:arcTo hR="132060" wR="132060" stAng="10800000" swAng="5400000"/>
+                <a:close/>
+              </a:path>
+            </a:pathLst>
+          </a:custGeom>
+          <a:solidFill>
+            <a:srgbClr val="B8492A"/>
+          </a:solidFill>
+          <a:ln/>
+        </p:spPr>
+        <p:txBody>
+          <a:bodyPr wrap="none" lIns="0" tIns="0" rIns="0" bIns="0" rtlCol="0" anchor="ctr">
+            <a:normAutofit/>
+          </a:bodyPr>
+          <a:lstStyle/>
+          <a:p>
+            <a:pPr algn="ctr" indent="0" marL="0">
+              <a:lnSpc>
+                <a:spcPts val="1680"/>
+              </a:lnSpc>
+              <a:buNone/>
+            </a:pPr>
+            <a:r>
+              <a:rPr lang="en-US" sz="1200" b="1" dirty="0">
+                <a:solidFill>
+                  <a:srgbClr val="FCFBF8"/>
+                </a:solidFill>
+                <a:latin typeface="IBM Plex Sans" pitchFamily="34" charset="0"/>
+                <a:ea typeface="IBM Plex Sans" pitchFamily="34" charset="-122"/>
+                <a:cs typeface="IBM Plex Sans" pitchFamily="34" charset="-120"/>
+              </a:rPr>
+              <a:t>bids 0.4</a:t>
+            </a:r>
+            <a:endParaRPr lang="en-US" sz="1200" dirty="0"/>
+          </a:p>
+        </p:txBody>
+      </p:sp>
+      <p:sp>
+        <p:nvSpPr>
+          <p:cNvPr id="18" name="Shape 16"/>
+          <p:cNvSpPr/>
+          <p:nvPr/>
+        </p:nvSpPr>
+        <p:spPr>
+          <a:xfrm>
+            <a:off x="6724650" y="2678311"/>
+            <a:ext cx="25400" cy="127000"/>
+          </a:xfrm>
+          <a:prstGeom prst="rect">
+            <a:avLst/>
+          </a:prstGeom>
+          <a:solidFill>
+            <a:srgbClr val="8D9AAE"/>
+          </a:solidFill>
+          <a:ln/>
+        </p:spPr>
+      </p:sp>
+      <p:sp>
+        <p:nvSpPr>
+          <p:cNvPr id="19" name="Text 17"/>
+          <p:cNvSpPr/>
+          <p:nvPr/>
+        </p:nvSpPr>
+        <p:spPr>
+          <a:xfrm>
+            <a:off x="6508750" y="2881511"/>
+            <a:ext cx="457200" cy="457200"/>
+          </a:xfrm>
+          <a:prstGeom prst="roundRect">
+            <a:avLst>
+              <a:gd name="adj" fmla="val 50000"/>
+            </a:avLst>
+          </a:prstGeom>
+          <a:solidFill>
+            <a:srgbClr val="14263D"/>
+          </a:solidFill>
+          <a:ln/>
+        </p:spPr>
+        <p:txBody>
+          <a:bodyPr wrap="square" lIns="0" tIns="0" rIns="0" bIns="0" rtlCol="0" anchor="ctr">
+            <a:normAutofit/>
+          </a:bodyPr>
+          <a:lstStyle/>
+          <a:p>
+            <a:pPr algn="ctr" indent="0" marL="0">
+              <a:lnSpc>
+                <a:spcPts val="1680"/>
+              </a:lnSpc>
+              <a:buNone/>
+            </a:pPr>
+            <a:r>
+              <a:rPr lang="en-US" sz="1200" b="1" dirty="0">
+                <a:solidFill>
+                  <a:srgbClr val="F2EFE8"/>
+                </a:solidFill>
+                <a:latin typeface="IBM Plex Sans" pitchFamily="34" charset="0"/>
+                <a:ea typeface="IBM Plex Sans" pitchFamily="34" charset="-122"/>
+                <a:cs typeface="IBM Plex Sans" pitchFamily="34" charset="-120"/>
+              </a:rPr>
+              <a:t>C2</a:t>
+            </a:r>
+            <a:endParaRPr lang="en-US" sz="1200" dirty="0"/>
+          </a:p>
+        </p:txBody>
+      </p:sp>
+      <p:sp>
+        <p:nvSpPr>
+          <p:cNvPr id="20" name="Text 18"/>
+          <p:cNvSpPr/>
+          <p:nvPr/>
+        </p:nvSpPr>
+        <p:spPr>
+          <a:xfrm>
+            <a:off x="7118350" y="3003451"/>
+            <a:ext cx="1066800" cy="238720"/>
+          </a:xfrm>
+          <a:prstGeom prst="rect">
+            <a:avLst/>
+          </a:prstGeom>
+          <a:noFill/>
+          <a:ln/>
+        </p:spPr>
+        <p:txBody>
+          <a:bodyPr wrap="square" lIns="0" tIns="0" rIns="0" bIns="0" rtlCol="0" anchor="t">
+            <a:normAutofit/>
+          </a:bodyPr>
+          <a:lstStyle/>
+          <a:p>
+            <a:pPr algn="l" indent="0" marL="0">
+              <a:lnSpc>
+                <a:spcPts val="1680"/>
+              </a:lnSpc>
+              <a:buNone/>
+            </a:pPr>
+            <a:r>
+              <a:rPr lang="en-US" sz="1200" dirty="0">
+                <a:solidFill>
+                  <a:srgbClr val="46546A"/>
+                </a:solidFill>
+                <a:latin typeface="IBM Plex Sans" pitchFamily="34" charset="0"/>
+                <a:ea typeface="IBM Plex Sans" pitchFamily="34" charset="-122"/>
+                <a:cs typeface="IBM Plex Sans" pitchFamily="34" charset="-120"/>
+              </a:rPr>
+              <a:t>value 0.85</a:t>
+            </a:r>
+            <a:endParaRPr lang="en-US" sz="1200" dirty="0"/>
+          </a:p>
+        </p:txBody>
+      </p:sp>
+      <p:sp>
+        <p:nvSpPr>
+          <p:cNvPr id="21" name="Text 19"/>
+          <p:cNvSpPr/>
+          <p:nvPr/>
+        </p:nvSpPr>
+        <p:spPr>
+          <a:xfrm>
+            <a:off x="8293100" y="2984401"/>
+            <a:ext cx="2116832" cy="251420"/>
+          </a:xfrm>
+          <a:custGeom>
+            <a:avLst/>
+            <a:gdLst/>
+            <a:ahLst/>
+            <a:cxnLst/>
+            <a:rect l="l" t="t" r="r" b="b"/>
+            <a:pathLst>
+              <a:path w="2116832" h="251420">
+                <a:moveTo>
+                  <a:pt x="125710" y="0"/>
+                </a:moveTo>
+                <a:lnTo>
+                  <a:pt x="1991122" y="0"/>
+                </a:lnTo>
+                <a:arcTo hR="125710" wR="125710" stAng="16200000" swAng="5400000"/>
+                <a:lnTo>
+                  <a:pt x="2116832" y="125710"/>
+                </a:lnTo>
+                <a:arcTo hR="125710" wR="125710" stAng="0" swAng="5400000"/>
+                <a:lnTo>
+                  <a:pt x="125710" y="251420"/>
+                </a:lnTo>
+                <a:arcTo hR="125710" wR="125710" stAng="5400000" swAng="5400000"/>
+                <a:lnTo>
+                  <a:pt x="0" y="125710"/>
+                </a:lnTo>
+                <a:arcTo hR="125710" wR="125710" stAng="10800000" swAng="5400000"/>
+                <a:close/>
+              </a:path>
+            </a:pathLst>
+          </a:custGeom>
+          <a:noFill/>
+          <a:ln w="12700">
+            <a:solidFill>
+              <a:srgbClr val="A9B4C2"/>
+            </a:solidFill>
+            <a:prstDash val="solid"/>
+          </a:ln>
+        </p:spPr>
+        <p:txBody>
+          <a:bodyPr wrap="none" lIns="0" tIns="0" rIns="0" bIns="0" rtlCol="0" anchor="ctr">
+            <a:normAutofit/>
+          </a:bodyPr>
+          <a:lstStyle/>
+          <a:p>
+            <a:pPr algn="ctr" indent="0" marL="0">
+              <a:lnSpc>
+                <a:spcPts val="1680"/>
+              </a:lnSpc>
+              <a:buNone/>
+            </a:pPr>
+            <a:r>
+              <a:rPr lang="en-US" sz="1200" dirty="0">
+                <a:solidFill>
+                  <a:srgbClr val="5F6B7A"/>
+                </a:solidFill>
+                <a:latin typeface="IBM Plex Sans" pitchFamily="34" charset="0"/>
+                <a:ea typeface="IBM Plex Sans" pitchFamily="34" charset="-122"/>
+                <a:cs typeface="IBM Plex Sans" pitchFamily="34" charset="-120"/>
+              </a:rPr>
+              <a:t>no bid: conflicts with C1, C3</a:t>
+            </a:r>
+            <a:endParaRPr lang="en-US" sz="1200" dirty="0"/>
+          </a:p>
+        </p:txBody>
+      </p:sp>
+      <p:sp>
+        <p:nvSpPr>
+          <p:cNvPr id="22" name="Shape 20"/>
+          <p:cNvSpPr/>
+          <p:nvPr/>
+        </p:nvSpPr>
+        <p:spPr>
+          <a:xfrm>
+            <a:off x="6724650" y="3414911"/>
+            <a:ext cx="25400" cy="127000"/>
+          </a:xfrm>
+          <a:prstGeom prst="rect">
+            <a:avLst/>
+          </a:prstGeom>
+          <a:solidFill>
+            <a:srgbClr val="8D9AAE"/>
+          </a:solidFill>
+          <a:ln/>
+        </p:spPr>
+      </p:sp>
+      <p:sp>
+        <p:nvSpPr>
+          <p:cNvPr id="23" name="Text 21"/>
+          <p:cNvSpPr/>
+          <p:nvPr/>
+        </p:nvSpPr>
+        <p:spPr>
+          <a:xfrm>
+            <a:off x="6508750" y="3618111"/>
+            <a:ext cx="457200" cy="457200"/>
+          </a:xfrm>
+          <a:prstGeom prst="roundRect">
+            <a:avLst>
+              <a:gd name="adj" fmla="val 50000"/>
+            </a:avLst>
+          </a:prstGeom>
+          <a:solidFill>
+            <a:srgbClr val="14263D"/>
+          </a:solidFill>
+          <a:ln/>
+        </p:spPr>
+        <p:txBody>
+          <a:bodyPr wrap="square" lIns="0" tIns="0" rIns="0" bIns="0" rtlCol="0" anchor="ctr">
+            <a:normAutofit/>
+          </a:bodyPr>
+          <a:lstStyle/>
+          <a:p>
+            <a:pPr algn="ctr" indent="0" marL="0">
+              <a:lnSpc>
+                <a:spcPts val="1680"/>
+              </a:lnSpc>
+              <a:buNone/>
+            </a:pPr>
+            <a:r>
+              <a:rPr lang="en-US" sz="1200" b="1" dirty="0">
+                <a:solidFill>
+                  <a:srgbClr val="F2EFE8"/>
+                </a:solidFill>
+                <a:latin typeface="IBM Plex Sans" pitchFamily="34" charset="0"/>
+                <a:ea typeface="IBM Plex Sans" pitchFamily="34" charset="-122"/>
+                <a:cs typeface="IBM Plex Sans" pitchFamily="34" charset="-120"/>
+              </a:rPr>
+              <a:t>C3</a:t>
+            </a:r>
+            <a:endParaRPr lang="en-US" sz="1200" dirty="0"/>
+          </a:p>
+        </p:txBody>
+      </p:sp>
+      <p:sp>
+        <p:nvSpPr>
+          <p:cNvPr id="24" name="Text 22"/>
+          <p:cNvSpPr/>
+          <p:nvPr/>
+        </p:nvSpPr>
+        <p:spPr>
+          <a:xfrm>
+            <a:off x="7118350" y="3740051"/>
+            <a:ext cx="1066800" cy="238720"/>
+          </a:xfrm>
+          <a:prstGeom prst="rect">
+            <a:avLst/>
+          </a:prstGeom>
+          <a:noFill/>
+          <a:ln/>
+        </p:spPr>
+        <p:txBody>
+          <a:bodyPr wrap="square" lIns="0" tIns="0" rIns="0" bIns="0" rtlCol="0" anchor="t">
+            <a:normAutofit/>
+          </a:bodyPr>
+          <a:lstStyle/>
+          <a:p>
+            <a:pPr algn="l" indent="0" marL="0">
+              <a:lnSpc>
+                <a:spcPts val="1680"/>
+              </a:lnSpc>
+              <a:buNone/>
+            </a:pPr>
+            <a:r>
+              <a:rPr lang="en-US" sz="1200" dirty="0">
+                <a:solidFill>
+                  <a:srgbClr val="46546A"/>
+                </a:solidFill>
+                <a:latin typeface="IBM Plex Sans" pitchFamily="34" charset="0"/>
+                <a:ea typeface="IBM Plex Sans" pitchFamily="34" charset="-122"/>
+                <a:cs typeface="IBM Plex Sans" pitchFamily="34" charset="-120"/>
+              </a:rPr>
+              <a:t>value 0.78</a:t>
+            </a:r>
+            <a:endParaRPr lang="en-US" sz="1200" dirty="0"/>
+          </a:p>
+        </p:txBody>
+      </p:sp>
+      <p:sp>
+        <p:nvSpPr>
+          <p:cNvPr id="25" name="Text 23"/>
+          <p:cNvSpPr/>
+          <p:nvPr/>
+        </p:nvSpPr>
+        <p:spPr>
+          <a:xfrm>
+            <a:off x="8286750" y="3714651"/>
+            <a:ext cx="768499" cy="264120"/>
+          </a:xfrm>
+          <a:custGeom>
+            <a:avLst/>
+            <a:gdLst/>
+            <a:ahLst/>
+            <a:cxnLst/>
+            <a:rect l="l" t="t" r="r" b="b"/>
+            <a:pathLst>
+              <a:path w="768499" h="264120">
+                <a:moveTo>
+                  <a:pt x="132060" y="0"/>
+                </a:moveTo>
+                <a:lnTo>
+                  <a:pt x="636439" y="0"/>
+                </a:lnTo>
+                <a:arcTo hR="132060" wR="132060" stAng="16200000" swAng="5400000"/>
+                <a:lnTo>
+                  <a:pt x="768499" y="132060"/>
+                </a:lnTo>
+                <a:arcTo hR="132060" wR="132060" stAng="0" swAng="5400000"/>
+                <a:lnTo>
+                  <a:pt x="132060" y="264120"/>
+                </a:lnTo>
+                <a:arcTo hR="132060" wR="132060" stAng="5400000" swAng="5400000"/>
+                <a:lnTo>
+                  <a:pt x="0" y="132060"/>
+                </a:lnTo>
+                <a:arcTo hR="132060" wR="132060" stAng="10800000" swAng="5400000"/>
+                <a:close/>
+              </a:path>
+            </a:pathLst>
+          </a:custGeom>
+          <a:solidFill>
+            <a:srgbClr val="B8492A"/>
+          </a:solidFill>
+          <a:ln/>
+        </p:spPr>
+        <p:txBody>
+          <a:bodyPr wrap="none" lIns="0" tIns="0" rIns="0" bIns="0" rtlCol="0" anchor="ctr">
+            <a:normAutofit/>
+          </a:bodyPr>
+          <a:lstStyle/>
+          <a:p>
+            <a:pPr algn="ctr" indent="0" marL="0">
+              <a:lnSpc>
+                <a:spcPts val="1680"/>
+              </a:lnSpc>
+              <a:buNone/>
+            </a:pPr>
+            <a:r>
+              <a:rPr lang="en-US" sz="1200" b="1" dirty="0">
+                <a:solidFill>
+                  <a:srgbClr val="FCFBF8"/>
+                </a:solidFill>
+                <a:latin typeface="IBM Plex Sans" pitchFamily="34" charset="0"/>
+                <a:ea typeface="IBM Plex Sans" pitchFamily="34" charset="-122"/>
+                <a:cs typeface="IBM Plex Sans" pitchFamily="34" charset="-120"/>
+              </a:rPr>
+              <a:t>bids 0.3</a:t>
+            </a:r>
+            <a:endParaRPr lang="en-US" sz="1200" dirty="0"/>
+          </a:p>
+        </p:txBody>
+      </p:sp>
+      <p:sp>
+        <p:nvSpPr>
+          <p:cNvPr id="26" name="Shape 24"/>
+          <p:cNvSpPr/>
+          <p:nvPr/>
+        </p:nvSpPr>
+        <p:spPr>
+          <a:xfrm>
+            <a:off x="6724650" y="4151511"/>
+            <a:ext cx="25400" cy="127000"/>
+          </a:xfrm>
+          <a:prstGeom prst="rect">
+            <a:avLst/>
+          </a:prstGeom>
+          <a:solidFill>
+            <a:srgbClr val="8D9AAE"/>
+          </a:solidFill>
+          <a:ln/>
+        </p:spPr>
+      </p:sp>
+      <p:sp>
+        <p:nvSpPr>
+          <p:cNvPr id="27" name="Text 25"/>
+          <p:cNvSpPr/>
+          <p:nvPr/>
+        </p:nvSpPr>
+        <p:spPr>
+          <a:xfrm>
+            <a:off x="6508750" y="4354711"/>
+            <a:ext cx="457200" cy="457200"/>
+          </a:xfrm>
+          <a:prstGeom prst="roundRect">
+            <a:avLst>
+              <a:gd name="adj" fmla="val 50000"/>
+            </a:avLst>
+          </a:prstGeom>
+          <a:solidFill>
+            <a:srgbClr val="14263D"/>
+          </a:solidFill>
+          <a:ln/>
+        </p:spPr>
+        <p:txBody>
+          <a:bodyPr wrap="square" lIns="0" tIns="0" rIns="0" bIns="0" rtlCol="0" anchor="ctr">
+            <a:normAutofit/>
+          </a:bodyPr>
+          <a:lstStyle/>
+          <a:p>
+            <a:pPr algn="ctr" indent="0" marL="0">
+              <a:lnSpc>
+                <a:spcPts val="1680"/>
+              </a:lnSpc>
+              <a:buNone/>
+            </a:pPr>
+            <a:r>
+              <a:rPr lang="en-US" sz="1200" b="1" dirty="0">
+                <a:solidFill>
+                  <a:srgbClr val="F2EFE8"/>
+                </a:solidFill>
+                <a:latin typeface="IBM Plex Sans" pitchFamily="34" charset="0"/>
+                <a:ea typeface="IBM Plex Sans" pitchFamily="34" charset="-122"/>
+                <a:cs typeface="IBM Plex Sans" pitchFamily="34" charset="-120"/>
+              </a:rPr>
+              <a:t>C4</a:t>
+            </a:r>
+            <a:endParaRPr lang="en-US" sz="1200" dirty="0"/>
+          </a:p>
+        </p:txBody>
+      </p:sp>
+      <p:sp>
+        <p:nvSpPr>
+          <p:cNvPr id="28" name="Text 26"/>
+          <p:cNvSpPr/>
+          <p:nvPr/>
+        </p:nvSpPr>
+        <p:spPr>
+          <a:xfrm>
+            <a:off x="7118350" y="4476651"/>
+            <a:ext cx="1066800" cy="238720"/>
+          </a:xfrm>
+          <a:prstGeom prst="rect">
+            <a:avLst/>
+          </a:prstGeom>
+          <a:noFill/>
+          <a:ln/>
+        </p:spPr>
+        <p:txBody>
+          <a:bodyPr wrap="square" lIns="0" tIns="0" rIns="0" bIns="0" rtlCol="0" anchor="t">
+            <a:normAutofit/>
+          </a:bodyPr>
+          <a:lstStyle/>
+          <a:p>
+            <a:pPr algn="l" indent="0" marL="0">
+              <a:lnSpc>
+                <a:spcPts val="1680"/>
+              </a:lnSpc>
+              <a:buNone/>
+            </a:pPr>
+            <a:r>
+              <a:rPr lang="en-US" sz="1200" dirty="0">
+                <a:solidFill>
+                  <a:srgbClr val="46546A"/>
+                </a:solidFill>
+                <a:latin typeface="IBM Plex Sans" pitchFamily="34" charset="0"/>
+                <a:ea typeface="IBM Plex Sans" pitchFamily="34" charset="-122"/>
+                <a:cs typeface="IBM Plex Sans" pitchFamily="34" charset="-120"/>
+              </a:rPr>
+              <a:t>value 0.90</a:t>
+            </a:r>
+            <a:endParaRPr lang="en-US" sz="1200" dirty="0"/>
+          </a:p>
+        </p:txBody>
+      </p:sp>
+      <p:sp>
+        <p:nvSpPr>
+          <p:cNvPr id="29" name="Text 27"/>
+          <p:cNvSpPr/>
+          <p:nvPr/>
+        </p:nvSpPr>
+        <p:spPr>
+          <a:xfrm>
+            <a:off x="8293100" y="4457601"/>
+            <a:ext cx="1853307" cy="251420"/>
+          </a:xfrm>
+          <a:custGeom>
+            <a:avLst/>
+            <a:gdLst/>
+            <a:ahLst/>
+            <a:cxnLst/>
+            <a:rect l="l" t="t" r="r" b="b"/>
+            <a:pathLst>
+              <a:path w="1853307" h="251420">
+                <a:moveTo>
+                  <a:pt x="125710" y="0"/>
+                </a:moveTo>
+                <a:lnTo>
+                  <a:pt x="1727597" y="0"/>
+                </a:lnTo>
+                <a:arcTo hR="125710" wR="125710" stAng="16200000" swAng="5400000"/>
+                <a:lnTo>
+                  <a:pt x="1853307" y="125710"/>
+                </a:lnTo>
+                <a:arcTo hR="125710" wR="125710" stAng="0" swAng="5400000"/>
+                <a:lnTo>
+                  <a:pt x="125710" y="251420"/>
+                </a:lnTo>
+                <a:arcTo hR="125710" wR="125710" stAng="5400000" swAng="5400000"/>
+                <a:lnTo>
+                  <a:pt x="0" y="125710"/>
+                </a:lnTo>
+                <a:arcTo hR="125710" wR="125710" stAng="10800000" swAng="5400000"/>
+                <a:close/>
+              </a:path>
+            </a:pathLst>
+          </a:custGeom>
+          <a:noFill/>
+          <a:ln w="12700">
+            <a:solidFill>
+              <a:srgbClr val="A9B4C2"/>
+            </a:solidFill>
+            <a:prstDash val="solid"/>
+          </a:ln>
+        </p:spPr>
+        <p:txBody>
+          <a:bodyPr wrap="none" lIns="0" tIns="0" rIns="0" bIns="0" rtlCol="0" anchor="ctr">
+            <a:normAutofit/>
+          </a:bodyPr>
+          <a:lstStyle/>
+          <a:p>
+            <a:pPr algn="ctr" indent="0" marL="0">
+              <a:lnSpc>
+                <a:spcPts val="1680"/>
+              </a:lnSpc>
+              <a:buNone/>
+            </a:pPr>
+            <a:r>
+              <a:rPr lang="en-US" sz="1200" dirty="0">
+                <a:solidFill>
+                  <a:srgbClr val="5F6B7A"/>
+                </a:solidFill>
+                <a:latin typeface="IBM Plex Sans" pitchFamily="34" charset="0"/>
+                <a:ea typeface="IBM Plex Sans" pitchFamily="34" charset="-122"/>
+                <a:cs typeface="IBM Plex Sans" pitchFamily="34" charset="-120"/>
+              </a:rPr>
+              <a:t>no bid: conflicts with C3</a:t>
+            </a:r>
+            <a:endParaRPr lang="en-US" sz="1200" dirty="0"/>
+          </a:p>
+        </p:txBody>
+      </p:sp>
+      <p:sp>
+        <p:nvSpPr>
+          <p:cNvPr id="30" name="Text 28"/>
+          <p:cNvSpPr/>
+          <p:nvPr/>
+        </p:nvSpPr>
+        <p:spPr>
+          <a:xfrm>
+            <a:off x="6508750" y="4964311"/>
+            <a:ext cx="4800727" cy="452041"/>
+          </a:xfrm>
+          <a:prstGeom prst="rect">
+            <a:avLst/>
+          </a:prstGeom>
+          <a:noFill/>
+          <a:ln/>
+        </p:spPr>
+        <p:txBody>
+          <a:bodyPr wrap="square" lIns="0" tIns="0" rIns="0" bIns="0" rtlCol="0" anchor="t">
+            <a:normAutofit/>
+          </a:bodyPr>
+          <a:lstStyle/>
+          <a:p>
+            <a:pPr algn="l" indent="0" marL="0">
+              <a:lnSpc>
+                <a:spcPts val="1680"/>
+              </a:lnSpc>
+              <a:buNone/>
+            </a:pPr>
+            <a:r>
+              <a:rPr lang="en-US" sz="1200" dirty="0">
+                <a:solidFill>
+                  <a:srgbClr val="5F6B7A"/>
+                </a:solidFill>
+                <a:latin typeface="IBM Plex Sans" pitchFamily="34" charset="0"/>
+                <a:ea typeface="IBM Plex Sans" pitchFamily="34" charset="-122"/>
+                <a:cs typeface="IBM Plex Sans" pitchFamily="34" charset="-120"/>
+              </a:rPr>
+              <a:t>Adjacent campaigns cannot bid in the same round. Illustrative combination, not a recorded action.</a:t>
+            </a:r>
+            <a:endParaRPr lang="en-US" sz="1200" dirty="0"/>
+          </a:p>
+        </p:txBody>
+      </p:sp>
+      <p:sp>
+        <p:nvSpPr>
+          <p:cNvPr id="31" name="Text 29"/>
           <p:cNvSpPr/>
           <p:nvPr/>
         </p:nvSpPr>
@@ -31456,7 +31595,7 @@
       </p:sp>
       <p:sp>
         <p:nvSpPr>
-          <p:cNvPr id="27" name="Text 25"/>
+          <p:cNvPr id="32" name="Text 30"/>
           <p:cNvSpPr/>
           <p:nvPr/>
         </p:nvSpPr>

</xml_diff>